<commit_message>
feat: add background video and presentation file for Ian Tweedie
</commit_message>
<xml_diff>
--- a/static/ppt/me.pptx
+++ b/static/ppt/me.pptx
@@ -261,7 +261,7 @@
           <a:p>
             <a:fld id="{E4263F41-6423-4831-B419-AF8BB67BCDB1}" type="datetimeFigureOut">
               <a:rPr lang="en-GB" smtClean="0"/>
-              <a:t>26/11/2025</a:t>
+              <a:t>29/04/2026</a:t>
             </a:fld>
             <a:endParaRPr lang="en-GB"/>
           </a:p>
@@ -461,7 +461,7 @@
           <a:p>
             <a:fld id="{E4263F41-6423-4831-B419-AF8BB67BCDB1}" type="datetimeFigureOut">
               <a:rPr lang="en-GB" smtClean="0"/>
-              <a:t>26/11/2025</a:t>
+              <a:t>29/04/2026</a:t>
             </a:fld>
             <a:endParaRPr lang="en-GB"/>
           </a:p>
@@ -671,7 +671,7 @@
           <a:p>
             <a:fld id="{E4263F41-6423-4831-B419-AF8BB67BCDB1}" type="datetimeFigureOut">
               <a:rPr lang="en-GB" smtClean="0"/>
-              <a:t>26/11/2025</a:t>
+              <a:t>29/04/2026</a:t>
             </a:fld>
             <a:endParaRPr lang="en-GB"/>
           </a:p>
@@ -871,7 +871,7 @@
           <a:p>
             <a:fld id="{E4263F41-6423-4831-B419-AF8BB67BCDB1}" type="datetimeFigureOut">
               <a:rPr lang="en-GB" smtClean="0"/>
-              <a:t>26/11/2025</a:t>
+              <a:t>29/04/2026</a:t>
             </a:fld>
             <a:endParaRPr lang="en-GB"/>
           </a:p>
@@ -1147,7 +1147,7 @@
           <a:p>
             <a:fld id="{E4263F41-6423-4831-B419-AF8BB67BCDB1}" type="datetimeFigureOut">
               <a:rPr lang="en-GB" smtClean="0"/>
-              <a:t>26/11/2025</a:t>
+              <a:t>29/04/2026</a:t>
             </a:fld>
             <a:endParaRPr lang="en-GB"/>
           </a:p>
@@ -1415,7 +1415,7 @@
           <a:p>
             <a:fld id="{E4263F41-6423-4831-B419-AF8BB67BCDB1}" type="datetimeFigureOut">
               <a:rPr lang="en-GB" smtClean="0"/>
-              <a:t>26/11/2025</a:t>
+              <a:t>29/04/2026</a:t>
             </a:fld>
             <a:endParaRPr lang="en-GB"/>
           </a:p>
@@ -1830,7 +1830,7 @@
           <a:p>
             <a:fld id="{E4263F41-6423-4831-B419-AF8BB67BCDB1}" type="datetimeFigureOut">
               <a:rPr lang="en-GB" smtClean="0"/>
-              <a:t>26/11/2025</a:t>
+              <a:t>29/04/2026</a:t>
             </a:fld>
             <a:endParaRPr lang="en-GB"/>
           </a:p>
@@ -1972,7 +1972,7 @@
           <a:p>
             <a:fld id="{E4263F41-6423-4831-B419-AF8BB67BCDB1}" type="datetimeFigureOut">
               <a:rPr lang="en-GB" smtClean="0"/>
-              <a:t>26/11/2025</a:t>
+              <a:t>29/04/2026</a:t>
             </a:fld>
             <a:endParaRPr lang="en-GB"/>
           </a:p>
@@ -2085,7 +2085,7 @@
           <a:p>
             <a:fld id="{E4263F41-6423-4831-B419-AF8BB67BCDB1}" type="datetimeFigureOut">
               <a:rPr lang="en-GB" smtClean="0"/>
-              <a:t>26/11/2025</a:t>
+              <a:t>29/04/2026</a:t>
             </a:fld>
             <a:endParaRPr lang="en-GB"/>
           </a:p>
@@ -2398,7 +2398,7 @@
           <a:p>
             <a:fld id="{E4263F41-6423-4831-B419-AF8BB67BCDB1}" type="datetimeFigureOut">
               <a:rPr lang="en-GB" smtClean="0"/>
-              <a:t>26/11/2025</a:t>
+              <a:t>29/04/2026</a:t>
             </a:fld>
             <a:endParaRPr lang="en-GB"/>
           </a:p>
@@ -2687,7 +2687,7 @@
           <a:p>
             <a:fld id="{E4263F41-6423-4831-B419-AF8BB67BCDB1}" type="datetimeFigureOut">
               <a:rPr lang="en-GB" smtClean="0"/>
-              <a:t>26/11/2025</a:t>
+              <a:t>29/04/2026</a:t>
             </a:fld>
             <a:endParaRPr lang="en-GB"/>
           </a:p>
@@ -2930,7 +2930,7 @@
           <a:p>
             <a:fld id="{E4263F41-6423-4831-B419-AF8BB67BCDB1}" type="datetimeFigureOut">
               <a:rPr lang="en-GB" smtClean="0"/>
-              <a:t>26/11/2025</a:t>
+              <a:t>29/04/2026</a:t>
             </a:fld>
             <a:endParaRPr lang="en-GB"/>
           </a:p>
@@ -3434,7 +3434,7 @@
         <p:spPr>
           <a:xfrm>
             <a:off x="2209367" y="1079743"/>
-            <a:ext cx="8992338" cy="5355312"/>
+            <a:ext cx="8992338" cy="4801314"/>
           </a:xfrm>
           <a:prstGeom prst="rect">
             <a:avLst/>
@@ -3650,42 +3650,6 @@
             </a:r>
           </a:p>
           <a:p>
-            <a:pPr marL="285750" indent="-285750">
-              <a:buFont typeface="Arial" panose="020B0604020202020204" pitchFamily="34" charset="0"/>
-              <a:buChar char="•"/>
-            </a:pPr>
-            <a:r>
-              <a:rPr lang="en-GB" b="0" dirty="0">
-                <a:effectLst/>
-                <a:latin typeface="Quicksand" pitchFamily="2" charset="0"/>
-              </a:rPr>
-              <a:t>Mentoring Hub</a:t>
-            </a:r>
-          </a:p>
-          <a:p>
-            <a:pPr marL="285750" indent="-285750">
-              <a:buFont typeface="Arial" panose="020B0604020202020204" pitchFamily="34" charset="0"/>
-              <a:buChar char="•"/>
-            </a:pPr>
-            <a:r>
-              <a:rPr lang="en-GB" b="0" dirty="0">
-                <a:effectLst/>
-                <a:latin typeface="Quicksand" pitchFamily="2" charset="0"/>
-              </a:rPr>
-              <a:t>Organizing committee of the </a:t>
-            </a:r>
-            <a:r>
-              <a:rPr lang="en-GB" b="1" dirty="0">
-                <a:effectLst/>
-                <a:latin typeface="Quicksand" pitchFamily="2" charset="0"/>
-              </a:rPr>
-              <a:t>East of England Summit</a:t>
-            </a:r>
-          </a:p>
-          <a:p>
-            <a:pPr>
-              <a:buNone/>
-            </a:pPr>
             <a:br>
               <a:rPr lang="en-GB" b="0" dirty="0">
                 <a:effectLst/>
@@ -3765,7 +3729,7 @@
         </p:blipFill>
         <p:spPr>
           <a:xfrm>
-            <a:off x="10598173" y="5903820"/>
+            <a:off x="9305292" y="5553975"/>
             <a:ext cx="1220128" cy="792049"/>
           </a:xfrm>
           <a:prstGeom prst="rect">
@@ -3802,7 +3766,7 @@
         </p:blipFill>
         <p:spPr bwMode="auto">
           <a:xfrm>
-            <a:off x="8467847" y="6086880"/>
+            <a:off x="7174966" y="5737035"/>
             <a:ext cx="1916675" cy="425928"/>
           </a:xfrm>
           <a:prstGeom prst="rect">
@@ -3842,7 +3806,7 @@
         </p:blipFill>
         <p:spPr>
           <a:xfrm>
-            <a:off x="3756477" y="6068525"/>
+            <a:off x="3536475" y="5737035"/>
             <a:ext cx="1807476" cy="524246"/>
           </a:xfrm>
           <a:prstGeom prst="rect">
@@ -3872,7 +3836,7 @@
         </p:blipFill>
         <p:spPr>
           <a:xfrm>
-            <a:off x="6916872" y="5982169"/>
+            <a:off x="5623991" y="5632324"/>
             <a:ext cx="1247396" cy="656841"/>
           </a:xfrm>
           <a:prstGeom prst="rect">
@@ -3882,10 +3846,10 @@
       </p:pic>
       <p:pic>
         <p:nvPicPr>
-          <p:cNvPr id="15" name="Picture 14">
-            <a:extLst>
-              <a:ext uri="{FF2B5EF4-FFF2-40B4-BE49-F238E27FC236}">
-                <a16:creationId xmlns:a16="http://schemas.microsoft.com/office/drawing/2014/main" id="{D7D88909-46BE-2572-CA24-0EF811A22876}"/>
+          <p:cNvPr id="17" name="Picture 16">
+            <a:extLst>
+              <a:ext uri="{FF2B5EF4-FFF2-40B4-BE49-F238E27FC236}">
+                <a16:creationId xmlns:a16="http://schemas.microsoft.com/office/drawing/2014/main" id="{D07E3DDE-D959-354C-FFEB-51A74F7F0CD1}"/>
               </a:ext>
             </a:extLst>
           </p:cNvPr>
@@ -3896,76 +3860,14 @@
         </p:nvPicPr>
         <p:blipFill>
           <a:blip r:embed="rId8"/>
-          <a:srcRect l="3910" t="15487" r="76531" b="7681"/>
           <a:stretch>
             <a:fillRect/>
           </a:stretch>
         </p:blipFill>
         <p:spPr>
           <a:xfrm>
-            <a:off x="5807315" y="5903820"/>
-            <a:ext cx="866195" cy="853657"/>
-          </a:xfrm>
-          <a:prstGeom prst="rect">
-            <a:avLst/>
-          </a:prstGeom>
-        </p:spPr>
-      </p:pic>
-      <p:pic>
-        <p:nvPicPr>
-          <p:cNvPr id="16" name="Picture 15">
-            <a:extLst>
-              <a:ext uri="{FF2B5EF4-FFF2-40B4-BE49-F238E27FC236}">
-                <a16:creationId xmlns:a16="http://schemas.microsoft.com/office/drawing/2014/main" id="{DAA88067-B656-28F0-01B2-EFFC92DB82A9}"/>
-              </a:ext>
-            </a:extLst>
-          </p:cNvPr>
-          <p:cNvPicPr>
-            <a:picLocks noChangeAspect="1"/>
-          </p:cNvPicPr>
-          <p:nvPr/>
-        </p:nvPicPr>
-        <p:blipFill>
-          <a:blip r:embed="rId9"/>
-          <a:srcRect l="21097" t="11419" r="21613" b="23032"/>
-          <a:stretch>
-            <a:fillRect/>
-          </a:stretch>
-        </p:blipFill>
-        <p:spPr>
-          <a:xfrm>
-            <a:off x="2690877" y="5890550"/>
-            <a:ext cx="769305" cy="880195"/>
-          </a:xfrm>
-          <a:prstGeom prst="rect">
-            <a:avLst/>
-          </a:prstGeom>
-        </p:spPr>
-      </p:pic>
-      <p:pic>
-        <p:nvPicPr>
-          <p:cNvPr id="17" name="Picture 16">
-            <a:extLst>
-              <a:ext uri="{FF2B5EF4-FFF2-40B4-BE49-F238E27FC236}">
-                <a16:creationId xmlns:a16="http://schemas.microsoft.com/office/drawing/2014/main" id="{D07E3DDE-D959-354C-FFEB-51A74F7F0CD1}"/>
-              </a:ext>
-            </a:extLst>
-          </p:cNvPr>
-          <p:cNvPicPr>
-            <a:picLocks noChangeAspect="1"/>
-          </p:cNvPicPr>
-          <p:nvPr/>
-        </p:nvPicPr>
-        <p:blipFill>
-          <a:blip r:embed="rId10"/>
-          <a:stretch>
-            <a:fillRect/>
-          </a:stretch>
-        </p:blipFill>
-        <p:spPr>
-          <a:xfrm>
-            <a:off x="5807315" y="1208579"/>
-            <a:ext cx="1167717" cy="656841"/>
+            <a:off x="9091641" y="0"/>
+            <a:ext cx="2515023" cy="1414701"/>
           </a:xfrm>
           <a:prstGeom prst="rect">
             <a:avLst/>
@@ -3987,7 +3889,7 @@
           <p:nvPr/>
         </p:nvPicPr>
         <p:blipFill>
-          <a:blip r:embed="rId11"/>
+          <a:blip r:embed="rId9"/>
           <a:srcRect l="14235" t="4634" r="14457" b="8463"/>
           <a:stretch>
             <a:fillRect/>
@@ -3995,8 +3897,8 @@
         </p:blipFill>
         <p:spPr>
           <a:xfrm>
-            <a:off x="1496220" y="5763180"/>
-            <a:ext cx="898362" cy="1094820"/>
+            <a:off x="2399504" y="5304110"/>
+            <a:ext cx="946835" cy="1153893"/>
           </a:xfrm>
           <a:prstGeom prst="rect">
             <a:avLst/>
@@ -4018,7 +3920,7 @@
           <p:nvPr/>
         </p:nvPicPr>
         <p:blipFill>
-          <a:blip r:embed="rId12">
+          <a:blip r:embed="rId10">
             <a:extLst>
               <a:ext uri="{28A0092B-C50C-407E-A947-70E740481C1C}">
                 <a14:useLocalDpi xmlns:a14="http://schemas.microsoft.com/office/drawing/2010/main" val="0"/>
@@ -4032,7 +3934,7 @@
         </p:blipFill>
         <p:spPr bwMode="auto">
           <a:xfrm rot="200049">
-            <a:off x="11088120" y="2448715"/>
+            <a:off x="11067099" y="3141868"/>
             <a:ext cx="737192" cy="3100601"/>
           </a:xfrm>
           <a:prstGeom prst="rect">

</xml_diff>